<commit_message>
Fix overlapping elements in slides: separate bullets from example box, expand card height in five_questions
</commit_message>
<xml_diff>
--- a/planejamento_experimental_slides.pptx
+++ b/planejamento_experimental_slides.pptx
@@ -4845,7 +4845,7 @@
         <p:spPr>
           <a:xfrm>
             <a:off x="822960" y="1874519"/>
-            <a:ext cx="10515600" cy="4206240"/>
+            <a:ext cx="10515600" cy="3200400"/>
           </a:xfrm>
           <a:prstGeom prst="rect">
             <a:avLst/>
@@ -4981,7 +4981,7 @@
         </p:nvSpPr>
         <p:spPr>
           <a:xfrm>
-            <a:off x="822960" y="5349240"/>
+            <a:off x="822960" y="5230368"/>
             <a:ext cx="10515600" cy="1051560"/>
           </a:xfrm>
           <a:prstGeom prst="roundRect">
@@ -5025,7 +5025,7 @@
         </p:nvSpPr>
         <p:spPr>
           <a:xfrm>
-            <a:off x="1005840" y="5422392"/>
+            <a:off x="1005840" y="5303520"/>
             <a:ext cx="10149840" cy="914400"/>
           </a:xfrm>
           <a:prstGeom prst="rect">
@@ -8264,7 +8264,7 @@
         <p:spPr>
           <a:xfrm>
             <a:off x="822960" y="1874519"/>
-            <a:ext cx="10515600" cy="4206240"/>
+            <a:ext cx="10515600" cy="3200400"/>
           </a:xfrm>
           <a:prstGeom prst="rect">
             <a:avLst/>
@@ -8381,7 +8381,7 @@
         </p:nvSpPr>
         <p:spPr>
           <a:xfrm>
-            <a:off x="822960" y="5349240"/>
+            <a:off x="822960" y="5230368"/>
             <a:ext cx="10515600" cy="1051560"/>
           </a:xfrm>
           <a:prstGeom prst="roundRect">
@@ -8425,7 +8425,7 @@
         </p:nvSpPr>
         <p:spPr>
           <a:xfrm>
-            <a:off x="1005840" y="5422392"/>
+            <a:off x="1005840" y="5303520"/>
             <a:ext cx="10149840" cy="914400"/>
           </a:xfrm>
           <a:prstGeom prst="rect">
@@ -8699,7 +8699,7 @@
         <p:spPr>
           <a:xfrm>
             <a:off x="822960" y="1874519"/>
-            <a:ext cx="10515600" cy="4206240"/>
+            <a:ext cx="10515600" cy="3200400"/>
           </a:xfrm>
           <a:prstGeom prst="rect">
             <a:avLst/>
@@ -8835,7 +8835,7 @@
         </p:nvSpPr>
         <p:spPr>
           <a:xfrm>
-            <a:off x="822960" y="5349240"/>
+            <a:off x="822960" y="5230368"/>
             <a:ext cx="10515600" cy="1051560"/>
           </a:xfrm>
           <a:prstGeom prst="roundRect">
@@ -8879,7 +8879,7 @@
         </p:nvSpPr>
         <p:spPr>
           <a:xfrm>
-            <a:off x="1005840" y="5422392"/>
+            <a:off x="1005840" y="5303520"/>
             <a:ext cx="10149840" cy="914400"/>
           </a:xfrm>
           <a:prstGeom prst="rect">
@@ -10311,7 +10311,7 @@
         </p:nvSpPr>
         <p:spPr>
           <a:xfrm>
-            <a:off x="640080" y="1920240"/>
+            <a:off x="640080" y="1874520"/>
             <a:ext cx="640080" cy="640080"/>
           </a:xfrm>
           <a:prstGeom prst="ellipse">
@@ -10355,7 +10355,7 @@
         </p:nvSpPr>
         <p:spPr>
           <a:xfrm>
-            <a:off x="640080" y="1993392"/>
+            <a:off x="640080" y="1947672"/>
             <a:ext cx="640080" cy="548640"/>
           </a:xfrm>
           <a:prstGeom prst="rect">
@@ -10390,8 +10390,8 @@
         </p:nvSpPr>
         <p:spPr>
           <a:xfrm>
-            <a:off x="1463040" y="1828800"/>
-            <a:ext cx="10241280" cy="777240"/>
+            <a:off x="1463040" y="1783080"/>
+            <a:ext cx="10241280" cy="850392"/>
           </a:xfrm>
           <a:prstGeom prst="roundRect">
             <a:avLst/>
@@ -10436,8 +10436,8 @@
         </p:nvSpPr>
         <p:spPr>
           <a:xfrm>
-            <a:off x="1691640" y="1901952"/>
-            <a:ext cx="9966960" cy="411480"/>
+            <a:off x="1691640" y="1847088"/>
+            <a:ext cx="9966960" cy="420624"/>
           </a:xfrm>
           <a:prstGeom prst="rect">
             <a:avLst/>
@@ -10470,8 +10470,8 @@
         </p:nvSpPr>
         <p:spPr>
           <a:xfrm>
-            <a:off x="1691640" y="2286000"/>
-            <a:ext cx="9966960" cy="365760"/>
+            <a:off x="1691640" y="2249424"/>
+            <a:ext cx="9966960" cy="347472"/>
           </a:xfrm>
           <a:prstGeom prst="rect">
             <a:avLst/>
@@ -10504,7 +10504,7 @@
         </p:nvSpPr>
         <p:spPr>
           <a:xfrm>
-            <a:off x="640080" y="2807208"/>
+            <a:off x="640080" y="2816352"/>
             <a:ext cx="640080" cy="640080"/>
           </a:xfrm>
           <a:prstGeom prst="ellipse">
@@ -10548,7 +10548,7 @@
         </p:nvSpPr>
         <p:spPr>
           <a:xfrm>
-            <a:off x="640080" y="2880360"/>
+            <a:off x="640080" y="2889504"/>
             <a:ext cx="640080" cy="548640"/>
           </a:xfrm>
           <a:prstGeom prst="rect">
@@ -10583,8 +10583,8 @@
         </p:nvSpPr>
         <p:spPr>
           <a:xfrm>
-            <a:off x="1463040" y="2715768"/>
-            <a:ext cx="10241280" cy="777240"/>
+            <a:off x="1463040" y="2724912"/>
+            <a:ext cx="10241280" cy="850392"/>
           </a:xfrm>
           <a:prstGeom prst="roundRect">
             <a:avLst/>
@@ -10630,7 +10630,7 @@
         <p:spPr>
           <a:xfrm>
             <a:off x="1691640" y="2788920"/>
-            <a:ext cx="9966960" cy="411480"/>
+            <a:ext cx="9966960" cy="420624"/>
           </a:xfrm>
           <a:prstGeom prst="rect">
             <a:avLst/>
@@ -10663,8 +10663,8 @@
         </p:nvSpPr>
         <p:spPr>
           <a:xfrm>
-            <a:off x="1691640" y="3172968"/>
-            <a:ext cx="9966960" cy="365760"/>
+            <a:off x="1691640" y="3191256"/>
+            <a:ext cx="9966960" cy="347472"/>
           </a:xfrm>
           <a:prstGeom prst="rect">
             <a:avLst/>
@@ -10697,7 +10697,7 @@
         </p:nvSpPr>
         <p:spPr>
           <a:xfrm>
-            <a:off x="640080" y="3694176"/>
+            <a:off x="640080" y="3758184"/>
             <a:ext cx="640080" cy="640080"/>
           </a:xfrm>
           <a:prstGeom prst="ellipse">
@@ -10741,7 +10741,7 @@
         </p:nvSpPr>
         <p:spPr>
           <a:xfrm>
-            <a:off x="640080" y="3767328"/>
+            <a:off x="640080" y="3831336"/>
             <a:ext cx="640080" cy="548640"/>
           </a:xfrm>
           <a:prstGeom prst="rect">
@@ -10776,8 +10776,8 @@
         </p:nvSpPr>
         <p:spPr>
           <a:xfrm>
-            <a:off x="1463040" y="3602736"/>
-            <a:ext cx="10241280" cy="777240"/>
+            <a:off x="1463040" y="3666744"/>
+            <a:ext cx="10241280" cy="850392"/>
           </a:xfrm>
           <a:prstGeom prst="roundRect">
             <a:avLst/>
@@ -10822,8 +10822,8 @@
         </p:nvSpPr>
         <p:spPr>
           <a:xfrm>
-            <a:off x="1691640" y="3675888"/>
-            <a:ext cx="9966960" cy="411480"/>
+            <a:off x="1691640" y="3730752"/>
+            <a:ext cx="9966960" cy="420624"/>
           </a:xfrm>
           <a:prstGeom prst="rect">
             <a:avLst/>
@@ -10856,8 +10856,8 @@
         </p:nvSpPr>
         <p:spPr>
           <a:xfrm>
-            <a:off x="1691640" y="4059936"/>
-            <a:ext cx="9966960" cy="365760"/>
+            <a:off x="1691640" y="4133088"/>
+            <a:ext cx="9966960" cy="347472"/>
           </a:xfrm>
           <a:prstGeom prst="rect">
             <a:avLst/>
@@ -10890,7 +10890,7 @@
         </p:nvSpPr>
         <p:spPr>
           <a:xfrm>
-            <a:off x="640080" y="4581144"/>
+            <a:off x="640080" y="4700016"/>
             <a:ext cx="640080" cy="640080"/>
           </a:xfrm>
           <a:prstGeom prst="ellipse">
@@ -10934,7 +10934,7 @@
         </p:nvSpPr>
         <p:spPr>
           <a:xfrm>
-            <a:off x="640080" y="4654296"/>
+            <a:off x="640080" y="4773168"/>
             <a:ext cx="640080" cy="548640"/>
           </a:xfrm>
           <a:prstGeom prst="rect">
@@ -10969,8 +10969,8 @@
         </p:nvSpPr>
         <p:spPr>
           <a:xfrm>
-            <a:off x="1463040" y="4489704"/>
-            <a:ext cx="10241280" cy="777240"/>
+            <a:off x="1463040" y="4608576"/>
+            <a:ext cx="10241280" cy="850392"/>
           </a:xfrm>
           <a:prstGeom prst="roundRect">
             <a:avLst/>
@@ -11015,8 +11015,8 @@
         </p:nvSpPr>
         <p:spPr>
           <a:xfrm>
-            <a:off x="1691640" y="4562856"/>
-            <a:ext cx="9966960" cy="411480"/>
+            <a:off x="1691640" y="4672584"/>
+            <a:ext cx="9966960" cy="420624"/>
           </a:xfrm>
           <a:prstGeom prst="rect">
             <a:avLst/>
@@ -11049,8 +11049,8 @@
         </p:nvSpPr>
         <p:spPr>
           <a:xfrm>
-            <a:off x="1691640" y="4946904"/>
-            <a:ext cx="9966960" cy="365760"/>
+            <a:off x="1691640" y="5074920"/>
+            <a:ext cx="9966960" cy="347472"/>
           </a:xfrm>
           <a:prstGeom prst="rect">
             <a:avLst/>
@@ -11083,7 +11083,7 @@
         </p:nvSpPr>
         <p:spPr>
           <a:xfrm>
-            <a:off x="640080" y="5468112"/>
+            <a:off x="640080" y="5641848"/>
             <a:ext cx="640080" cy="640080"/>
           </a:xfrm>
           <a:prstGeom prst="ellipse">
@@ -11127,7 +11127,7 @@
         </p:nvSpPr>
         <p:spPr>
           <a:xfrm>
-            <a:off x="640080" y="5541264"/>
+            <a:off x="640080" y="5715000"/>
             <a:ext cx="640080" cy="548640"/>
           </a:xfrm>
           <a:prstGeom prst="rect">
@@ -11162,8 +11162,8 @@
         </p:nvSpPr>
         <p:spPr>
           <a:xfrm>
-            <a:off x="1463040" y="5376672"/>
-            <a:ext cx="10241280" cy="777240"/>
+            <a:off x="1463040" y="5550408"/>
+            <a:ext cx="10241280" cy="850392"/>
           </a:xfrm>
           <a:prstGeom prst="roundRect">
             <a:avLst/>
@@ -11208,8 +11208,8 @@
         </p:nvSpPr>
         <p:spPr>
           <a:xfrm>
-            <a:off x="1691640" y="5449824"/>
-            <a:ext cx="9966960" cy="411480"/>
+            <a:off x="1691640" y="5614416"/>
+            <a:ext cx="9966960" cy="420624"/>
           </a:xfrm>
           <a:prstGeom prst="rect">
             <a:avLst/>
@@ -11242,8 +11242,8 @@
         </p:nvSpPr>
         <p:spPr>
           <a:xfrm>
-            <a:off x="1691640" y="5833872"/>
-            <a:ext cx="9966960" cy="365760"/>
+            <a:off x="1691640" y="6016752"/>
+            <a:ext cx="9966960" cy="347472"/>
           </a:xfrm>
           <a:prstGeom prst="rect">
             <a:avLst/>
@@ -13151,7 +13151,7 @@
         <p:spPr>
           <a:xfrm>
             <a:off x="822960" y="1874519"/>
-            <a:ext cx="10515600" cy="4206240"/>
+            <a:ext cx="10515600" cy="3200400"/>
           </a:xfrm>
           <a:prstGeom prst="rect">
             <a:avLst/>
@@ -13268,7 +13268,7 @@
         </p:nvSpPr>
         <p:spPr>
           <a:xfrm>
-            <a:off x="822960" y="5349240"/>
+            <a:off x="822960" y="5230368"/>
             <a:ext cx="10515600" cy="1051560"/>
           </a:xfrm>
           <a:prstGeom prst="roundRect">
@@ -13312,7 +13312,7 @@
         </p:nvSpPr>
         <p:spPr>
           <a:xfrm>
-            <a:off x="1005840" y="5422392"/>
+            <a:off x="1005840" y="5303520"/>
             <a:ext cx="10149840" cy="914400"/>
           </a:xfrm>
           <a:prstGeom prst="rect">
@@ -13586,7 +13586,7 @@
         <p:spPr>
           <a:xfrm>
             <a:off x="822960" y="1874519"/>
-            <a:ext cx="10515600" cy="4206240"/>
+            <a:ext cx="10515600" cy="3200400"/>
           </a:xfrm>
           <a:prstGeom prst="rect">
             <a:avLst/>
@@ -13703,7 +13703,7 @@
         </p:nvSpPr>
         <p:spPr>
           <a:xfrm>
-            <a:off x="822960" y="5349240"/>
+            <a:off x="822960" y="5230368"/>
             <a:ext cx="10515600" cy="1051560"/>
           </a:xfrm>
           <a:prstGeom prst="roundRect">
@@ -13747,7 +13747,7 @@
         </p:nvSpPr>
         <p:spPr>
           <a:xfrm>
-            <a:off x="1005840" y="5422392"/>
+            <a:off x="1005840" y="5303520"/>
             <a:ext cx="10149840" cy="914400"/>
           </a:xfrm>
           <a:prstGeom prst="rect">
@@ -14021,7 +14021,7 @@
         <p:spPr>
           <a:xfrm>
             <a:off x="822960" y="1874519"/>
-            <a:ext cx="10515600" cy="4206240"/>
+            <a:ext cx="10515600" cy="3200400"/>
           </a:xfrm>
           <a:prstGeom prst="rect">
             <a:avLst/>
@@ -14138,7 +14138,7 @@
         </p:nvSpPr>
         <p:spPr>
           <a:xfrm>
-            <a:off x="822960" y="5349240"/>
+            <a:off x="822960" y="5230368"/>
             <a:ext cx="10515600" cy="1051560"/>
           </a:xfrm>
           <a:prstGeom prst="roundRect">
@@ -14182,7 +14182,7 @@
         </p:nvSpPr>
         <p:spPr>
           <a:xfrm>
-            <a:off x="1005840" y="5422392"/>
+            <a:off x="1005840" y="5303520"/>
             <a:ext cx="10149840" cy="914400"/>
           </a:xfrm>
           <a:prstGeom prst="rect">

</xml_diff>